<commit_message>
Update PowerPoint for song #233 in FUBC - Українські
</commit_message>
<xml_diff>
--- a/fubc-ua/233-Я не хочу марно часу провести (Пісні Спасенних №232).pptx
+++ b/fubc-ua/233-Я не хочу марно часу провести (Пісні Спасенних №232).pptx
@@ -685,7 +685,7 @@
           <a:p>
             <a:r>
               <a:rPr lang="en-US" dirty="0"/>
-              <a:t>P · 1/1 · rows:1,2,1,1,1,1</a:t>
+              <a:t>P · 1/1 · rows:1,1,1,2</a:t>
             </a:r>
             <a:endParaRPr lang="en-US" dirty="0"/>
           </a:p>
@@ -861,7 +861,7 @@
           <a:p>
             <a:r>
               <a:rPr lang="en-US" dirty="0"/>
-              <a:t>P · 1/1 · rows:1,2,1,1,1,1</a:t>
+              <a:t>P · 1/1 · rows:1,1,1,2</a:t>
             </a:r>
             <a:endParaRPr lang="en-US" dirty="0"/>
           </a:p>
@@ -1037,7 +1037,7 @@
           <a:p>
             <a:r>
               <a:rPr lang="en-US" dirty="0"/>
-              <a:t>P · 1/1 · rows:1,2,1,1,1,1</a:t>
+              <a:t>P · 1/1 · rows:1,1,1,2</a:t>
             </a:r>
             <a:endParaRPr lang="en-US" dirty="0"/>
           </a:p>
@@ -1767,92 +1767,41 @@
               <a:buNone/>
             </a:pPr>
             <a:r>
-              <a:rPr lang="en-US" sz="5100" b="1" i="1" dirty="0">
-                <a:solidFill>
-                  <a:srgbClr val="FFFFFF"/>
-                </a:solidFill>
-                <a:latin typeface="Arial" pitchFamily="34" charset="0"/>
-                <a:ea typeface="Arial" pitchFamily="34" charset="-122"/>
-                <a:cs typeface="Arial" pitchFamily="34" charset="-120"/>
-              </a:rPr>
-              <a:t>Понесу (понесу)</a:t>
-            </a:r>
-            <a:endParaRPr lang="en-US" sz="5100" dirty="0"/>
-          </a:p>
-          <a:p>
-            <a:pPr algn="ctr" indent="0" marL="0">
-              <a:buNone/>
-            </a:pPr>
-            <a:r>
-              <a:rPr lang="en-US" sz="5100" b="1" i="1" dirty="0">
-                <a:solidFill>
-                  <a:srgbClr val="FFFFFF"/>
-                </a:solidFill>
-                <a:latin typeface="Arial" pitchFamily="34" charset="0"/>
-                <a:ea typeface="Arial" pitchFamily="34" charset="-122"/>
-                <a:cs typeface="Arial" pitchFamily="34" charset="-120"/>
-              </a:rPr>
-              <a:t>вість про Христа</a:t>
-            </a:r>
-            <a:endParaRPr lang="en-US" sz="5100" dirty="0"/>
-          </a:p>
-          <a:p>
-            <a:pPr algn="ctr" indent="0" marL="0">
-              <a:buNone/>
-            </a:pPr>
-            <a:r>
-              <a:rPr lang="en-US" sz="5100" b="1" i="1" dirty="0">
-                <a:solidFill>
-                  <a:srgbClr val="FFFFFF"/>
-                </a:solidFill>
-                <a:latin typeface="Arial" pitchFamily="34" charset="0"/>
-                <a:ea typeface="Arial" pitchFamily="34" charset="-122"/>
-                <a:cs typeface="Arial" pitchFamily="34" charset="-120"/>
-              </a:rPr>
-              <a:t>(вість про Христа)</a:t>
-            </a:r>
-            <a:endParaRPr lang="en-US" sz="5100" dirty="0"/>
-          </a:p>
-          <a:p>
-            <a:pPr algn="ctr" indent="0" marL="0">
-              <a:buNone/>
-            </a:pPr>
-            <a:r>
-              <a:rPr lang="en-US" sz="5100" b="1" i="1" dirty="0">
-                <a:solidFill>
-                  <a:srgbClr val="FFFFFF"/>
-                </a:solidFill>
-                <a:latin typeface="Arial" pitchFamily="34" charset="0"/>
-                <a:ea typeface="Arial" pitchFamily="34" charset="-122"/>
-                <a:cs typeface="Arial" pitchFamily="34" charset="-120"/>
-              </a:rPr>
-              <a:t>по землі (по землі)</a:t>
-            </a:r>
-            <a:endParaRPr lang="en-US" sz="5100" dirty="0"/>
-          </a:p>
-          <a:p>
-            <a:pPr algn="ctr" indent="0" marL="0">
-              <a:buNone/>
-            </a:pPr>
-            <a:r>
-              <a:rPr lang="en-US" sz="5100" b="1" i="1" dirty="0">
-                <a:solidFill>
-                  <a:srgbClr val="FFFFFF"/>
-                </a:solidFill>
-                <a:latin typeface="Arial" pitchFamily="34" charset="0"/>
-                <a:ea typeface="Arial" pitchFamily="34" charset="-122"/>
-                <a:cs typeface="Arial" pitchFamily="34" charset="-120"/>
-              </a:rPr>
-              <a:t>в усі місця (в усі місця),</a:t>
-            </a:r>
-            <a:endParaRPr lang="en-US" sz="5100" dirty="0"/>
-          </a:p>
-          <a:p>
-            <a:pPr algn="ctr" indent="0" marL="0">
-              <a:buNone/>
-            </a:pPr>
-            <a:r>
-              <a:rPr lang="en-US" sz="5100" b="1" i="1" dirty="0">
+              <a:rPr lang="en-US" sz="5200" b="1" i="1" dirty="0">
+                <a:solidFill>
+                  <a:srgbClr val="FFFFFF"/>
+                </a:solidFill>
+                <a:latin typeface="Arial" pitchFamily="34" charset="0"/>
+                <a:ea typeface="Arial" pitchFamily="34" charset="-122"/>
+                <a:cs typeface="Arial" pitchFamily="34" charset="-120"/>
+              </a:rPr>
+              <a:t>Понесу вість про Христа</a:t>
+            </a:r>
+            <a:endParaRPr lang="en-US" sz="5200" dirty="0"/>
+          </a:p>
+          <a:p>
+            <a:pPr algn="ctr" indent="0" marL="0">
+              <a:buNone/>
+            </a:pPr>
+            <a:r>
+              <a:rPr lang="en-US" sz="5200" b="1" i="1" dirty="0">
+                <a:solidFill>
+                  <a:srgbClr val="FFFFFF"/>
+                </a:solidFill>
+                <a:latin typeface="Arial" pitchFamily="34" charset="0"/>
+                <a:ea typeface="Arial" pitchFamily="34" charset="-122"/>
+                <a:cs typeface="Arial" pitchFamily="34" charset="-120"/>
+              </a:rPr>
+              <a:t>по землі в усі місця,</a:t>
+            </a:r>
+            <a:endParaRPr lang="en-US" sz="5200" dirty="0"/>
+          </a:p>
+          <a:p>
+            <a:pPr algn="ctr" indent="0" marL="0">
+              <a:buNone/>
+            </a:pPr>
+            <a:r>
+              <a:rPr lang="en-US" sz="5200" b="1" i="1" dirty="0">
                 <a:solidFill>
                   <a:srgbClr val="FFFFFF"/>
                 </a:solidFill>
@@ -1862,24 +1811,41 @@
               </a:rPr>
               <a:t>щоб Його любов пізнали люди всі</a:t>
             </a:r>
-            <a:endParaRPr lang="en-US" sz="5100" dirty="0"/>
-          </a:p>
-          <a:p>
-            <a:pPr algn="ctr" indent="0" marL="0">
-              <a:buNone/>
-            </a:pPr>
-            <a:r>
-              <a:rPr lang="en-US" sz="5100" b="1" i="1" dirty="0">
-                <a:solidFill>
-                  <a:srgbClr val="FFFFFF"/>
-                </a:solidFill>
-                <a:latin typeface="Arial" pitchFamily="34" charset="0"/>
-                <a:ea typeface="Arial" pitchFamily="34" charset="-122"/>
-                <a:cs typeface="Arial" pitchFamily="34" charset="-120"/>
-              </a:rPr>
-              <a:t>і блаженство вічне в Нім знайшли.</a:t>
-            </a:r>
-            <a:endParaRPr lang="en-US" sz="5100" dirty="0"/>
+            <a:endParaRPr lang="en-US" sz="5200" dirty="0"/>
+          </a:p>
+          <a:p>
+            <a:pPr algn="ctr" indent="0" marL="0">
+              <a:buNone/>
+            </a:pPr>
+            <a:r>
+              <a:rPr lang="en-US" sz="5200" b="1" i="1" dirty="0">
+                <a:solidFill>
+                  <a:srgbClr val="FFFFFF"/>
+                </a:solidFill>
+                <a:latin typeface="Arial" pitchFamily="34" charset="0"/>
+                <a:ea typeface="Arial" pitchFamily="34" charset="-122"/>
+                <a:cs typeface="Arial" pitchFamily="34" charset="-120"/>
+              </a:rPr>
+              <a:t>і блаженство вічне</a:t>
+            </a:r>
+            <a:endParaRPr lang="en-US" sz="5200" dirty="0"/>
+          </a:p>
+          <a:p>
+            <a:pPr algn="ctr" indent="0" marL="0">
+              <a:buNone/>
+            </a:pPr>
+            <a:r>
+              <a:rPr lang="en-US" sz="5200" b="1" i="1" dirty="0">
+                <a:solidFill>
+                  <a:srgbClr val="FFFFFF"/>
+                </a:solidFill>
+                <a:latin typeface="Arial" pitchFamily="34" charset="0"/>
+                <a:ea typeface="Arial" pitchFamily="34" charset="-122"/>
+                <a:cs typeface="Arial" pitchFamily="34" charset="-120"/>
+              </a:rPr>
+              <a:t>в Нім знайшли.</a:t>
+            </a:r>
+            <a:endParaRPr lang="en-US" sz="5200" dirty="0"/>
           </a:p>
         </p:txBody>
       </p:sp>
@@ -2096,92 +2062,41 @@
               <a:buNone/>
             </a:pPr>
             <a:r>
-              <a:rPr lang="en-US" sz="5100" b="1" i="1" dirty="0">
-                <a:solidFill>
-                  <a:srgbClr val="FFFFFF"/>
-                </a:solidFill>
-                <a:latin typeface="Arial" pitchFamily="34" charset="0"/>
-                <a:ea typeface="Arial" pitchFamily="34" charset="-122"/>
-                <a:cs typeface="Arial" pitchFamily="34" charset="-120"/>
-              </a:rPr>
-              <a:t>Понесу (понесу)</a:t>
-            </a:r>
-            <a:endParaRPr lang="en-US" sz="5100" dirty="0"/>
-          </a:p>
-          <a:p>
-            <a:pPr algn="ctr" indent="0" marL="0">
-              <a:buNone/>
-            </a:pPr>
-            <a:r>
-              <a:rPr lang="en-US" sz="5100" b="1" i="1" dirty="0">
-                <a:solidFill>
-                  <a:srgbClr val="FFFFFF"/>
-                </a:solidFill>
-                <a:latin typeface="Arial" pitchFamily="34" charset="0"/>
-                <a:ea typeface="Arial" pitchFamily="34" charset="-122"/>
-                <a:cs typeface="Arial" pitchFamily="34" charset="-120"/>
-              </a:rPr>
-              <a:t>вість про Христа</a:t>
-            </a:r>
-            <a:endParaRPr lang="en-US" sz="5100" dirty="0"/>
-          </a:p>
-          <a:p>
-            <a:pPr algn="ctr" indent="0" marL="0">
-              <a:buNone/>
-            </a:pPr>
-            <a:r>
-              <a:rPr lang="en-US" sz="5100" b="1" i="1" dirty="0">
-                <a:solidFill>
-                  <a:srgbClr val="FFFFFF"/>
-                </a:solidFill>
-                <a:latin typeface="Arial" pitchFamily="34" charset="0"/>
-                <a:ea typeface="Arial" pitchFamily="34" charset="-122"/>
-                <a:cs typeface="Arial" pitchFamily="34" charset="-120"/>
-              </a:rPr>
-              <a:t>(вість про Христа)</a:t>
-            </a:r>
-            <a:endParaRPr lang="en-US" sz="5100" dirty="0"/>
-          </a:p>
-          <a:p>
-            <a:pPr algn="ctr" indent="0" marL="0">
-              <a:buNone/>
-            </a:pPr>
-            <a:r>
-              <a:rPr lang="en-US" sz="5100" b="1" i="1" dirty="0">
-                <a:solidFill>
-                  <a:srgbClr val="FFFFFF"/>
-                </a:solidFill>
-                <a:latin typeface="Arial" pitchFamily="34" charset="0"/>
-                <a:ea typeface="Arial" pitchFamily="34" charset="-122"/>
-                <a:cs typeface="Arial" pitchFamily="34" charset="-120"/>
-              </a:rPr>
-              <a:t>по землі (по землі)</a:t>
-            </a:r>
-            <a:endParaRPr lang="en-US" sz="5100" dirty="0"/>
-          </a:p>
-          <a:p>
-            <a:pPr algn="ctr" indent="0" marL="0">
-              <a:buNone/>
-            </a:pPr>
-            <a:r>
-              <a:rPr lang="en-US" sz="5100" b="1" i="1" dirty="0">
-                <a:solidFill>
-                  <a:srgbClr val="FFFFFF"/>
-                </a:solidFill>
-                <a:latin typeface="Arial" pitchFamily="34" charset="0"/>
-                <a:ea typeface="Arial" pitchFamily="34" charset="-122"/>
-                <a:cs typeface="Arial" pitchFamily="34" charset="-120"/>
-              </a:rPr>
-              <a:t>в усі місця (в усі місця),</a:t>
-            </a:r>
-            <a:endParaRPr lang="en-US" sz="5100" dirty="0"/>
-          </a:p>
-          <a:p>
-            <a:pPr algn="ctr" indent="0" marL="0">
-              <a:buNone/>
-            </a:pPr>
-            <a:r>
-              <a:rPr lang="en-US" sz="5100" b="1" i="1" dirty="0">
+              <a:rPr lang="en-US" sz="5200" b="1" i="1" dirty="0">
+                <a:solidFill>
+                  <a:srgbClr val="FFFFFF"/>
+                </a:solidFill>
+                <a:latin typeface="Arial" pitchFamily="34" charset="0"/>
+                <a:ea typeface="Arial" pitchFamily="34" charset="-122"/>
+                <a:cs typeface="Arial" pitchFamily="34" charset="-120"/>
+              </a:rPr>
+              <a:t>Понесу вість про Христа</a:t>
+            </a:r>
+            <a:endParaRPr lang="en-US" sz="5200" dirty="0"/>
+          </a:p>
+          <a:p>
+            <a:pPr algn="ctr" indent="0" marL="0">
+              <a:buNone/>
+            </a:pPr>
+            <a:r>
+              <a:rPr lang="en-US" sz="5200" b="1" i="1" dirty="0">
+                <a:solidFill>
+                  <a:srgbClr val="FFFFFF"/>
+                </a:solidFill>
+                <a:latin typeface="Arial" pitchFamily="34" charset="0"/>
+                <a:ea typeface="Arial" pitchFamily="34" charset="-122"/>
+                <a:cs typeface="Arial" pitchFamily="34" charset="-120"/>
+              </a:rPr>
+              <a:t>по землі в усі місця,</a:t>
+            </a:r>
+            <a:endParaRPr lang="en-US" sz="5200" dirty="0"/>
+          </a:p>
+          <a:p>
+            <a:pPr algn="ctr" indent="0" marL="0">
+              <a:buNone/>
+            </a:pPr>
+            <a:r>
+              <a:rPr lang="en-US" sz="5200" b="1" i="1" dirty="0">
                 <a:solidFill>
                   <a:srgbClr val="FFFFFF"/>
                 </a:solidFill>
@@ -2191,24 +2106,41 @@
               </a:rPr>
               <a:t>щоб Його любов пізнали люди всі</a:t>
             </a:r>
-            <a:endParaRPr lang="en-US" sz="5100" dirty="0"/>
-          </a:p>
-          <a:p>
-            <a:pPr algn="ctr" indent="0" marL="0">
-              <a:buNone/>
-            </a:pPr>
-            <a:r>
-              <a:rPr lang="en-US" sz="5100" b="1" i="1" dirty="0">
-                <a:solidFill>
-                  <a:srgbClr val="FFFFFF"/>
-                </a:solidFill>
-                <a:latin typeface="Arial" pitchFamily="34" charset="0"/>
-                <a:ea typeface="Arial" pitchFamily="34" charset="-122"/>
-                <a:cs typeface="Arial" pitchFamily="34" charset="-120"/>
-              </a:rPr>
-              <a:t>і блаженство вічне в Нім знайшли.</a:t>
-            </a:r>
-            <a:endParaRPr lang="en-US" sz="5100" dirty="0"/>
+            <a:endParaRPr lang="en-US" sz="5200" dirty="0"/>
+          </a:p>
+          <a:p>
+            <a:pPr algn="ctr" indent="0" marL="0">
+              <a:buNone/>
+            </a:pPr>
+            <a:r>
+              <a:rPr lang="en-US" sz="5200" b="1" i="1" dirty="0">
+                <a:solidFill>
+                  <a:srgbClr val="FFFFFF"/>
+                </a:solidFill>
+                <a:latin typeface="Arial" pitchFamily="34" charset="0"/>
+                <a:ea typeface="Arial" pitchFamily="34" charset="-122"/>
+                <a:cs typeface="Arial" pitchFamily="34" charset="-120"/>
+              </a:rPr>
+              <a:t>і блаженство вічне</a:t>
+            </a:r>
+            <a:endParaRPr lang="en-US" sz="5200" dirty="0"/>
+          </a:p>
+          <a:p>
+            <a:pPr algn="ctr" indent="0" marL="0">
+              <a:buNone/>
+            </a:pPr>
+            <a:r>
+              <a:rPr lang="en-US" sz="5200" b="1" i="1" dirty="0">
+                <a:solidFill>
+                  <a:srgbClr val="FFFFFF"/>
+                </a:solidFill>
+                <a:latin typeface="Arial" pitchFamily="34" charset="0"/>
+                <a:ea typeface="Arial" pitchFamily="34" charset="-122"/>
+                <a:cs typeface="Arial" pitchFamily="34" charset="-120"/>
+              </a:rPr>
+              <a:t>в Нім знайшли.</a:t>
+            </a:r>
+            <a:endParaRPr lang="en-US" sz="5200" dirty="0"/>
           </a:p>
         </p:txBody>
       </p:sp>
@@ -2408,92 +2340,41 @@
               <a:buNone/>
             </a:pPr>
             <a:r>
-              <a:rPr lang="en-US" sz="5100" b="1" i="1" dirty="0">
-                <a:solidFill>
-                  <a:srgbClr val="FFFFFF"/>
-                </a:solidFill>
-                <a:latin typeface="Arial" pitchFamily="34" charset="0"/>
-                <a:ea typeface="Arial" pitchFamily="34" charset="-122"/>
-                <a:cs typeface="Arial" pitchFamily="34" charset="-120"/>
-              </a:rPr>
-              <a:t>Понесу (понесу)</a:t>
-            </a:r>
-            <a:endParaRPr lang="en-US" sz="5100" dirty="0"/>
-          </a:p>
-          <a:p>
-            <a:pPr algn="ctr" indent="0" marL="0">
-              <a:buNone/>
-            </a:pPr>
-            <a:r>
-              <a:rPr lang="en-US" sz="5100" b="1" i="1" dirty="0">
-                <a:solidFill>
-                  <a:srgbClr val="FFFFFF"/>
-                </a:solidFill>
-                <a:latin typeface="Arial" pitchFamily="34" charset="0"/>
-                <a:ea typeface="Arial" pitchFamily="34" charset="-122"/>
-                <a:cs typeface="Arial" pitchFamily="34" charset="-120"/>
-              </a:rPr>
-              <a:t>вість про Христа</a:t>
-            </a:r>
-            <a:endParaRPr lang="en-US" sz="5100" dirty="0"/>
-          </a:p>
-          <a:p>
-            <a:pPr algn="ctr" indent="0" marL="0">
-              <a:buNone/>
-            </a:pPr>
-            <a:r>
-              <a:rPr lang="en-US" sz="5100" b="1" i="1" dirty="0">
-                <a:solidFill>
-                  <a:srgbClr val="FFFFFF"/>
-                </a:solidFill>
-                <a:latin typeface="Arial" pitchFamily="34" charset="0"/>
-                <a:ea typeface="Arial" pitchFamily="34" charset="-122"/>
-                <a:cs typeface="Arial" pitchFamily="34" charset="-120"/>
-              </a:rPr>
-              <a:t>(вість про Христа)</a:t>
-            </a:r>
-            <a:endParaRPr lang="en-US" sz="5100" dirty="0"/>
-          </a:p>
-          <a:p>
-            <a:pPr algn="ctr" indent="0" marL="0">
-              <a:buNone/>
-            </a:pPr>
-            <a:r>
-              <a:rPr lang="en-US" sz="5100" b="1" i="1" dirty="0">
-                <a:solidFill>
-                  <a:srgbClr val="FFFFFF"/>
-                </a:solidFill>
-                <a:latin typeface="Arial" pitchFamily="34" charset="0"/>
-                <a:ea typeface="Arial" pitchFamily="34" charset="-122"/>
-                <a:cs typeface="Arial" pitchFamily="34" charset="-120"/>
-              </a:rPr>
-              <a:t>по землі (по землі)</a:t>
-            </a:r>
-            <a:endParaRPr lang="en-US" sz="5100" dirty="0"/>
-          </a:p>
-          <a:p>
-            <a:pPr algn="ctr" indent="0" marL="0">
-              <a:buNone/>
-            </a:pPr>
-            <a:r>
-              <a:rPr lang="en-US" sz="5100" b="1" i="1" dirty="0">
-                <a:solidFill>
-                  <a:srgbClr val="FFFFFF"/>
-                </a:solidFill>
-                <a:latin typeface="Arial" pitchFamily="34" charset="0"/>
-                <a:ea typeface="Arial" pitchFamily="34" charset="-122"/>
-                <a:cs typeface="Arial" pitchFamily="34" charset="-120"/>
-              </a:rPr>
-              <a:t>в усі місця (в усі місця),</a:t>
-            </a:r>
-            <a:endParaRPr lang="en-US" sz="5100" dirty="0"/>
-          </a:p>
-          <a:p>
-            <a:pPr algn="ctr" indent="0" marL="0">
-              <a:buNone/>
-            </a:pPr>
-            <a:r>
-              <a:rPr lang="en-US" sz="5100" b="1" i="1" dirty="0">
+              <a:rPr lang="en-US" sz="5200" b="1" i="1" dirty="0">
+                <a:solidFill>
+                  <a:srgbClr val="FFFFFF"/>
+                </a:solidFill>
+                <a:latin typeface="Arial" pitchFamily="34" charset="0"/>
+                <a:ea typeface="Arial" pitchFamily="34" charset="-122"/>
+                <a:cs typeface="Arial" pitchFamily="34" charset="-120"/>
+              </a:rPr>
+              <a:t>Понесу вість про Христа</a:t>
+            </a:r>
+            <a:endParaRPr lang="en-US" sz="5200" dirty="0"/>
+          </a:p>
+          <a:p>
+            <a:pPr algn="ctr" indent="0" marL="0">
+              <a:buNone/>
+            </a:pPr>
+            <a:r>
+              <a:rPr lang="en-US" sz="5200" b="1" i="1" dirty="0">
+                <a:solidFill>
+                  <a:srgbClr val="FFFFFF"/>
+                </a:solidFill>
+                <a:latin typeface="Arial" pitchFamily="34" charset="0"/>
+                <a:ea typeface="Arial" pitchFamily="34" charset="-122"/>
+                <a:cs typeface="Arial" pitchFamily="34" charset="-120"/>
+              </a:rPr>
+              <a:t>по землі в усі місця,</a:t>
+            </a:r>
+            <a:endParaRPr lang="en-US" sz="5200" dirty="0"/>
+          </a:p>
+          <a:p>
+            <a:pPr algn="ctr" indent="0" marL="0">
+              <a:buNone/>
+            </a:pPr>
+            <a:r>
+              <a:rPr lang="en-US" sz="5200" b="1" i="1" dirty="0">
                 <a:solidFill>
                   <a:srgbClr val="FFFFFF"/>
                 </a:solidFill>
@@ -2503,24 +2384,41 @@
               </a:rPr>
               <a:t>щоб Його любов пізнали люди всі</a:t>
             </a:r>
-            <a:endParaRPr lang="en-US" sz="5100" dirty="0"/>
-          </a:p>
-          <a:p>
-            <a:pPr algn="ctr" indent="0" marL="0">
-              <a:buNone/>
-            </a:pPr>
-            <a:r>
-              <a:rPr lang="en-US" sz="5100" b="1" i="1" dirty="0">
-                <a:solidFill>
-                  <a:srgbClr val="FFFFFF"/>
-                </a:solidFill>
-                <a:latin typeface="Arial" pitchFamily="34" charset="0"/>
-                <a:ea typeface="Arial" pitchFamily="34" charset="-122"/>
-                <a:cs typeface="Arial" pitchFamily="34" charset="-120"/>
-              </a:rPr>
-              <a:t>і блаженство вічне в Нім знайшли.</a:t>
-            </a:r>
-            <a:endParaRPr lang="en-US" sz="5100" dirty="0"/>
+            <a:endParaRPr lang="en-US" sz="5200" dirty="0"/>
+          </a:p>
+          <a:p>
+            <a:pPr algn="ctr" indent="0" marL="0">
+              <a:buNone/>
+            </a:pPr>
+            <a:r>
+              <a:rPr lang="en-US" sz="5200" b="1" i="1" dirty="0">
+                <a:solidFill>
+                  <a:srgbClr val="FFFFFF"/>
+                </a:solidFill>
+                <a:latin typeface="Arial" pitchFamily="34" charset="0"/>
+                <a:ea typeface="Arial" pitchFamily="34" charset="-122"/>
+                <a:cs typeface="Arial" pitchFamily="34" charset="-120"/>
+              </a:rPr>
+              <a:t>і блаженство вічне</a:t>
+            </a:r>
+            <a:endParaRPr lang="en-US" sz="5200" dirty="0"/>
+          </a:p>
+          <a:p>
+            <a:pPr algn="ctr" indent="0" marL="0">
+              <a:buNone/>
+            </a:pPr>
+            <a:r>
+              <a:rPr lang="en-US" sz="5200" b="1" i="1" dirty="0">
+                <a:solidFill>
+                  <a:srgbClr val="FFFFFF"/>
+                </a:solidFill>
+                <a:latin typeface="Arial" pitchFamily="34" charset="0"/>
+                <a:ea typeface="Arial" pitchFamily="34" charset="-122"/>
+                <a:cs typeface="Arial" pitchFamily="34" charset="-120"/>
+              </a:rPr>
+              <a:t>в Нім знайшли.</a:t>
+            </a:r>
+            <a:endParaRPr lang="en-US" sz="5200" dirty="0"/>
           </a:p>
         </p:txBody>
       </p:sp>

</xml_diff>